<commit_message>
Updated some es tutorials
</commit_message>
<xml_diff>
--- a/public/assets/ppt/IGT_AI_Tutoriales/Traducción SlicerIGT-U09_Models.pptx
+++ b/public/assets/ppt/IGT_AI_Tutoriales/Traducción SlicerIGT-U09_Models.pptx
@@ -122,319 +122,6 @@
 </p:presentation>
 </file>
 
-<file path=ppt/revisionInfo.xml><?xml version="1.0" encoding="utf-8"?>
-<p1510:revInfo xmlns:a="http://schemas.openxmlformats.org/drawingml/2006/main" xmlns:r="http://schemas.openxmlformats.org/officeDocument/2006/relationships" xmlns:p1510="http://schemas.microsoft.com/office/powerpoint/2015/10/main">
-  <p1510:revLst>
-    <p1510:client id="{5A9A6002-D6C4-9C6A-4B99-0C02C916C6B5}" v="112" dt="2025-10-01T15:57:05.726"/>
-  </p1510:revLst>
-</p1510:revInfo>
-</file>
-
-<file path=ppt/changesInfos/changesInfo1.xml><?xml version="1.0" encoding="utf-8"?>
-<pc:chgInfo xmlns:a="http://schemas.openxmlformats.org/drawingml/2006/main" xmlns:r="http://schemas.openxmlformats.org/officeDocument/2006/relationships" xmlns:ac="http://schemas.microsoft.com/office/drawing/2013/main/command" xmlns:pc="http://schemas.microsoft.com/office/powerpoint/2013/main/command">
-  <pc:docChgLst>
-    <pc:chgData name="Enrique Hernandez Laredo" userId="S::ehernandezl@uaemex.mx::0a776dbf-440b-483b-8adc-ce2eaa375c6c" providerId="AD" clId="Web-{5A9A6002-D6C4-9C6A-4B99-0C02C916C6B5}"/>
-    <pc:docChg chg="addSld delSld modSld">
-      <pc:chgData name="Enrique Hernandez Laredo" userId="S::ehernandezl@uaemex.mx::0a776dbf-440b-483b-8adc-ce2eaa375c6c" providerId="AD" clId="Web-{5A9A6002-D6C4-9C6A-4B99-0C02C916C6B5}" dt="2025-10-01T15:57:05.726" v="105"/>
-      <pc:docMkLst>
-        <pc:docMk/>
-      </pc:docMkLst>
-      <pc:sldChg chg="addSp delSp modSp">
-        <pc:chgData name="Enrique Hernandez Laredo" userId="S::ehernandezl@uaemex.mx::0a776dbf-440b-483b-8adc-ce2eaa375c6c" providerId="AD" clId="Web-{5A9A6002-D6C4-9C6A-4B99-0C02C916C6B5}" dt="2025-10-01T15:36:26.245" v="15" actId="1076"/>
-        <pc:sldMkLst>
-          <pc:docMk/>
-          <pc:sldMk cId="199115864" sldId="257"/>
-        </pc:sldMkLst>
-        <pc:spChg chg="mod">
-          <ac:chgData name="Enrique Hernandez Laredo" userId="S::ehernandezl@uaemex.mx::0a776dbf-440b-483b-8adc-ce2eaa375c6c" providerId="AD" clId="Web-{5A9A6002-D6C4-9C6A-4B99-0C02C916C6B5}" dt="2025-10-01T15:35:47.354" v="8" actId="1076"/>
-          <ac:spMkLst>
-            <pc:docMk/>
-            <pc:sldMk cId="199115864" sldId="257"/>
-            <ac:spMk id="3" creationId="{00000000-0000-0000-0000-000000000000}"/>
-          </ac:spMkLst>
-        </pc:spChg>
-        <pc:picChg chg="del">
-          <ac:chgData name="Enrique Hernandez Laredo" userId="S::ehernandezl@uaemex.mx::0a776dbf-440b-483b-8adc-ce2eaa375c6c" providerId="AD" clId="Web-{5A9A6002-D6C4-9C6A-4B99-0C02C916C6B5}" dt="2025-10-01T15:35:19.150" v="0"/>
-          <ac:picMkLst>
-            <pc:docMk/>
-            <pc:sldMk cId="199115864" sldId="257"/>
-            <ac:picMk id="5" creationId="{00000000-0000-0000-0000-000000000000}"/>
-          </ac:picMkLst>
-        </pc:picChg>
-        <pc:picChg chg="add mod modCrop">
-          <ac:chgData name="Enrique Hernandez Laredo" userId="S::ehernandezl@uaemex.mx::0a776dbf-440b-483b-8adc-ce2eaa375c6c" providerId="AD" clId="Web-{5A9A6002-D6C4-9C6A-4B99-0C02C916C6B5}" dt="2025-10-01T15:36:26.245" v="15" actId="1076"/>
-          <ac:picMkLst>
-            <pc:docMk/>
-            <pc:sldMk cId="199115864" sldId="257"/>
-            <ac:picMk id="10" creationId="{30554E05-39B0-E26D-6E75-D48399B442A8}"/>
-          </ac:picMkLst>
-        </pc:picChg>
-      </pc:sldChg>
-      <pc:sldChg chg="addSp delSp modSp">
-        <pc:chgData name="Enrique Hernandez Laredo" userId="S::ehernandezl@uaemex.mx::0a776dbf-440b-483b-8adc-ce2eaa375c6c" providerId="AD" clId="Web-{5A9A6002-D6C4-9C6A-4B99-0C02C916C6B5}" dt="2025-10-01T15:50:44.832" v="60" actId="14100"/>
-        <pc:sldMkLst>
-          <pc:docMk/>
-          <pc:sldMk cId="4140427666" sldId="258"/>
-        </pc:sldMkLst>
-        <pc:picChg chg="add del">
-          <ac:chgData name="Enrique Hernandez Laredo" userId="S::ehernandezl@uaemex.mx::0a776dbf-440b-483b-8adc-ce2eaa375c6c" providerId="AD" clId="Web-{5A9A6002-D6C4-9C6A-4B99-0C02C916C6B5}" dt="2025-10-01T15:37:07.339" v="17"/>
-          <ac:picMkLst>
-            <pc:docMk/>
-            <pc:sldMk cId="4140427666" sldId="258"/>
-            <ac:picMk id="5" creationId="{00000000-0000-0000-0000-000000000000}"/>
-          </ac:picMkLst>
-        </pc:picChg>
-        <pc:picChg chg="add mod">
-          <ac:chgData name="Enrique Hernandez Laredo" userId="S::ehernandezl@uaemex.mx::0a776dbf-440b-483b-8adc-ce2eaa375c6c" providerId="AD" clId="Web-{5A9A6002-D6C4-9C6A-4B99-0C02C916C6B5}" dt="2025-10-01T15:50:44.832" v="60" actId="14100"/>
-          <ac:picMkLst>
-            <pc:docMk/>
-            <pc:sldMk cId="4140427666" sldId="258"/>
-            <ac:picMk id="6" creationId="{2406151B-8BDC-A79A-0778-08A7E58D5C5D}"/>
-          </ac:picMkLst>
-        </pc:picChg>
-        <pc:picChg chg="mod">
-          <ac:chgData name="Enrique Hernandez Laredo" userId="S::ehernandezl@uaemex.mx::0a776dbf-440b-483b-8adc-ce2eaa375c6c" providerId="AD" clId="Web-{5A9A6002-D6C4-9C6A-4B99-0C02C916C6B5}" dt="2025-10-01T15:37:52.933" v="19" actId="1076"/>
-          <ac:picMkLst>
-            <pc:docMk/>
-            <pc:sldMk cId="4140427666" sldId="258"/>
-            <ac:picMk id="1026" creationId="{00000000-0000-0000-0000-000000000000}"/>
-          </ac:picMkLst>
-        </pc:picChg>
-      </pc:sldChg>
-      <pc:sldChg chg="modSp">
-        <pc:chgData name="Enrique Hernandez Laredo" userId="S::ehernandezl@uaemex.mx::0a776dbf-440b-483b-8adc-ce2eaa375c6c" providerId="AD" clId="Web-{5A9A6002-D6C4-9C6A-4B99-0C02C916C6B5}" dt="2025-10-01T15:50:43.988" v="59" actId="20577"/>
-        <pc:sldMkLst>
-          <pc:docMk/>
-          <pc:sldMk cId="273597443" sldId="261"/>
-        </pc:sldMkLst>
-        <pc:spChg chg="mod">
-          <ac:chgData name="Enrique Hernandez Laredo" userId="S::ehernandezl@uaemex.mx::0a776dbf-440b-483b-8adc-ce2eaa375c6c" providerId="AD" clId="Web-{5A9A6002-D6C4-9C6A-4B99-0C02C916C6B5}" dt="2025-10-01T15:50:43.988" v="59" actId="20577"/>
-          <ac:spMkLst>
-            <pc:docMk/>
-            <pc:sldMk cId="273597443" sldId="261"/>
-            <ac:spMk id="3" creationId="{00000000-0000-0000-0000-000000000000}"/>
-          </ac:spMkLst>
-        </pc:spChg>
-      </pc:sldChg>
-      <pc:sldChg chg="del">
-        <pc:chgData name="Enrique Hernandez Laredo" userId="S::ehernandezl@uaemex.mx::0a776dbf-440b-483b-8adc-ce2eaa375c6c" providerId="AD" clId="Web-{5A9A6002-D6C4-9C6A-4B99-0C02C916C6B5}" dt="2025-10-01T15:57:05.726" v="105"/>
-        <pc:sldMkLst>
-          <pc:docMk/>
-          <pc:sldMk cId="3441692595" sldId="262"/>
-        </pc:sldMkLst>
-      </pc:sldChg>
-      <pc:sldChg chg="addSp delSp modSp add replId">
-        <pc:chgData name="Enrique Hernandez Laredo" userId="S::ehernandezl@uaemex.mx::0a776dbf-440b-483b-8adc-ce2eaa375c6c" providerId="AD" clId="Web-{5A9A6002-D6C4-9C6A-4B99-0C02C916C6B5}" dt="2025-10-01T15:56:49.225" v="104" actId="1076"/>
-        <pc:sldMkLst>
-          <pc:docMk/>
-          <pc:sldMk cId="2352843823" sldId="264"/>
-        </pc:sldMkLst>
-        <pc:spChg chg="mod">
-          <ac:chgData name="Enrique Hernandez Laredo" userId="S::ehernandezl@uaemex.mx::0a776dbf-440b-483b-8adc-ce2eaa375c6c" providerId="AD" clId="Web-{5A9A6002-D6C4-9C6A-4B99-0C02C916C6B5}" dt="2025-10-01T15:52:45.601" v="73" actId="1076"/>
-          <ac:spMkLst>
-            <pc:docMk/>
-            <pc:sldMk cId="2352843823" sldId="264"/>
-            <ac:spMk id="2" creationId="{8A179885-B663-0CCE-9E33-CE26F0654062}"/>
-          </ac:spMkLst>
-        </pc:spChg>
-        <pc:spChg chg="mod">
-          <ac:chgData name="Enrique Hernandez Laredo" userId="S::ehernandezl@uaemex.mx::0a776dbf-440b-483b-8adc-ce2eaa375c6c" providerId="AD" clId="Web-{5A9A6002-D6C4-9C6A-4B99-0C02C916C6B5}" dt="2025-10-01T15:53:36.241" v="84" actId="1076"/>
-          <ac:spMkLst>
-            <pc:docMk/>
-            <pc:sldMk cId="2352843823" sldId="264"/>
-            <ac:spMk id="6" creationId="{BA9B42FD-E459-8FFD-6988-6F9DE10BE0D9}"/>
-          </ac:spMkLst>
-        </pc:spChg>
-        <pc:spChg chg="mod">
-          <ac:chgData name="Enrique Hernandez Laredo" userId="S::ehernandezl@uaemex.mx::0a776dbf-440b-483b-8adc-ce2eaa375c6c" providerId="AD" clId="Web-{5A9A6002-D6C4-9C6A-4B99-0C02C916C6B5}" dt="2025-10-01T15:54:03.601" v="86" actId="1076"/>
-          <ac:spMkLst>
-            <pc:docMk/>
-            <pc:sldMk cId="2352843823" sldId="264"/>
-            <ac:spMk id="7" creationId="{7B08B694-0278-611E-DCEE-7E2ED4A244A1}"/>
-          </ac:spMkLst>
-        </pc:spChg>
-        <pc:spChg chg="mod">
-          <ac:chgData name="Enrique Hernandez Laredo" userId="S::ehernandezl@uaemex.mx::0a776dbf-440b-483b-8adc-ce2eaa375c6c" providerId="AD" clId="Web-{5A9A6002-D6C4-9C6A-4B99-0C02C916C6B5}" dt="2025-10-01T15:53:15.507" v="77" actId="1076"/>
-          <ac:spMkLst>
-            <pc:docMk/>
-            <pc:sldMk cId="2352843823" sldId="264"/>
-            <ac:spMk id="9" creationId="{88928081-DD25-A746-1228-D084013EA33C}"/>
-          </ac:spMkLst>
-        </pc:spChg>
-        <pc:spChg chg="mod">
-          <ac:chgData name="Enrique Hernandez Laredo" userId="S::ehernandezl@uaemex.mx::0a776dbf-440b-483b-8adc-ce2eaa375c6c" providerId="AD" clId="Web-{5A9A6002-D6C4-9C6A-4B99-0C02C916C6B5}" dt="2025-10-01T15:53:09.382" v="75" actId="1076"/>
-          <ac:spMkLst>
-            <pc:docMk/>
-            <pc:sldMk cId="2352843823" sldId="264"/>
-            <ac:spMk id="10" creationId="{03144948-5232-AB41-DF99-C459BD2231E4}"/>
-          </ac:spMkLst>
-        </pc:spChg>
-        <pc:spChg chg="mod">
-          <ac:chgData name="Enrique Hernandez Laredo" userId="S::ehernandezl@uaemex.mx::0a776dbf-440b-483b-8adc-ce2eaa375c6c" providerId="AD" clId="Web-{5A9A6002-D6C4-9C6A-4B99-0C02C916C6B5}" dt="2025-10-01T15:54:11.772" v="88" actId="1076"/>
-          <ac:spMkLst>
-            <pc:docMk/>
-            <pc:sldMk cId="2352843823" sldId="264"/>
-            <ac:spMk id="12" creationId="{11785559-2991-0BAD-DFC7-491C39DADE92}"/>
-          </ac:spMkLst>
-        </pc:spChg>
-        <pc:spChg chg="mod">
-          <ac:chgData name="Enrique Hernandez Laredo" userId="S::ehernandezl@uaemex.mx::0a776dbf-440b-483b-8adc-ce2eaa375c6c" providerId="AD" clId="Web-{5A9A6002-D6C4-9C6A-4B99-0C02C916C6B5}" dt="2025-10-01T15:56:44.069" v="101" actId="1076"/>
-          <ac:spMkLst>
-            <pc:docMk/>
-            <pc:sldMk cId="2352843823" sldId="264"/>
-            <ac:spMk id="14" creationId="{F554DAFC-F5FA-B248-1C4E-2B5518936B9D}"/>
-          </ac:spMkLst>
-        </pc:spChg>
-        <pc:spChg chg="mod">
-          <ac:chgData name="Enrique Hernandez Laredo" userId="S::ehernandezl@uaemex.mx::0a776dbf-440b-483b-8adc-ce2eaa375c6c" providerId="AD" clId="Web-{5A9A6002-D6C4-9C6A-4B99-0C02C916C6B5}" dt="2025-10-01T15:56:49.210" v="103" actId="1076"/>
-          <ac:spMkLst>
-            <pc:docMk/>
-            <pc:sldMk cId="2352843823" sldId="264"/>
-            <ac:spMk id="15" creationId="{CDBE93F6-E5E2-B89F-08CC-0E38639DE89B}"/>
-          </ac:spMkLst>
-        </pc:spChg>
-        <pc:spChg chg="mod">
-          <ac:chgData name="Enrique Hernandez Laredo" userId="S::ehernandezl@uaemex.mx::0a776dbf-440b-483b-8adc-ce2eaa375c6c" providerId="AD" clId="Web-{5A9A6002-D6C4-9C6A-4B99-0C02C916C6B5}" dt="2025-10-01T15:53:09.397" v="76" actId="1076"/>
-          <ac:spMkLst>
-            <pc:docMk/>
-            <pc:sldMk cId="2352843823" sldId="264"/>
-            <ac:spMk id="18" creationId="{6F072374-D594-B642-68BA-C20414040D68}"/>
-          </ac:spMkLst>
-        </pc:spChg>
-        <pc:spChg chg="mod">
-          <ac:chgData name="Enrique Hernandez Laredo" userId="S::ehernandezl@uaemex.mx::0a776dbf-440b-483b-8adc-ce2eaa375c6c" providerId="AD" clId="Web-{5A9A6002-D6C4-9C6A-4B99-0C02C916C6B5}" dt="2025-10-01T15:53:15.522" v="78" actId="1076"/>
-          <ac:spMkLst>
-            <pc:docMk/>
-            <pc:sldMk cId="2352843823" sldId="264"/>
-            <ac:spMk id="19" creationId="{B9ACA81F-FEEF-820B-7370-E214495A1CF7}"/>
-          </ac:spMkLst>
-        </pc:spChg>
-        <pc:spChg chg="mod">
-          <ac:chgData name="Enrique Hernandez Laredo" userId="S::ehernandezl@uaemex.mx::0a776dbf-440b-483b-8adc-ce2eaa375c6c" providerId="AD" clId="Web-{5A9A6002-D6C4-9C6A-4B99-0C02C916C6B5}" dt="2025-10-01T15:53:41.351" v="85" actId="1076"/>
-          <ac:spMkLst>
-            <pc:docMk/>
-            <pc:sldMk cId="2352843823" sldId="264"/>
-            <ac:spMk id="20" creationId="{CB10EFA0-5D33-5268-3C51-135E6F5EAAC3}"/>
-          </ac:spMkLst>
-        </pc:spChg>
-        <pc:spChg chg="mod">
-          <ac:chgData name="Enrique Hernandez Laredo" userId="S::ehernandezl@uaemex.mx::0a776dbf-440b-483b-8adc-ce2eaa375c6c" providerId="AD" clId="Web-{5A9A6002-D6C4-9C6A-4B99-0C02C916C6B5}" dt="2025-10-01T15:54:03.616" v="87" actId="1076"/>
-          <ac:spMkLst>
-            <pc:docMk/>
-            <pc:sldMk cId="2352843823" sldId="264"/>
-            <ac:spMk id="21" creationId="{EBF8C863-B126-18AA-AE5E-6054CDA4ABE1}"/>
-          </ac:spMkLst>
-        </pc:spChg>
-        <pc:spChg chg="mod">
-          <ac:chgData name="Enrique Hernandez Laredo" userId="S::ehernandezl@uaemex.mx::0a776dbf-440b-483b-8adc-ce2eaa375c6c" providerId="AD" clId="Web-{5A9A6002-D6C4-9C6A-4B99-0C02C916C6B5}" dt="2025-10-01T15:54:15.288" v="89" actId="1076"/>
-          <ac:spMkLst>
-            <pc:docMk/>
-            <pc:sldMk cId="2352843823" sldId="264"/>
-            <ac:spMk id="22" creationId="{A21A61A6-1650-61DD-6487-E13B65D6B008}"/>
-          </ac:spMkLst>
-        </pc:spChg>
-        <pc:spChg chg="mod">
-          <ac:chgData name="Enrique Hernandez Laredo" userId="S::ehernandezl@uaemex.mx::0a776dbf-440b-483b-8adc-ce2eaa375c6c" providerId="AD" clId="Web-{5A9A6002-D6C4-9C6A-4B99-0C02C916C6B5}" dt="2025-10-01T15:56:49.225" v="104" actId="1076"/>
-          <ac:spMkLst>
-            <pc:docMk/>
-            <pc:sldMk cId="2352843823" sldId="264"/>
-            <ac:spMk id="23" creationId="{FA00A13F-42EB-9FFE-DFEB-ABDAE614A617}"/>
-          </ac:spMkLst>
-        </pc:spChg>
-        <pc:spChg chg="mod">
-          <ac:chgData name="Enrique Hernandez Laredo" userId="S::ehernandezl@uaemex.mx::0a776dbf-440b-483b-8adc-ce2eaa375c6c" providerId="AD" clId="Web-{5A9A6002-D6C4-9C6A-4B99-0C02C916C6B5}" dt="2025-10-01T15:56:44.085" v="102" actId="1076"/>
-          <ac:spMkLst>
-            <pc:docMk/>
-            <pc:sldMk cId="2352843823" sldId="264"/>
-            <ac:spMk id="24" creationId="{1B9E5559-7C80-626A-4D90-990A9F3317AA}"/>
-          </ac:spMkLst>
-        </pc:spChg>
-        <pc:spChg chg="mod">
-          <ac:chgData name="Enrique Hernandez Laredo" userId="S::ehernandezl@uaemex.mx::0a776dbf-440b-483b-8adc-ce2eaa375c6c" providerId="AD" clId="Web-{5A9A6002-D6C4-9C6A-4B99-0C02C916C6B5}" dt="2025-10-01T15:56:17.038" v="98" actId="1076"/>
-          <ac:spMkLst>
-            <pc:docMk/>
-            <pc:sldMk cId="2352843823" sldId="264"/>
-            <ac:spMk id="25" creationId="{805F7F38-863F-2965-81D5-F0DEDEB400F8}"/>
-          </ac:spMkLst>
-        </pc:spChg>
-        <pc:spChg chg="mod">
-          <ac:chgData name="Enrique Hernandez Laredo" userId="S::ehernandezl@uaemex.mx::0a776dbf-440b-483b-8adc-ce2eaa375c6c" providerId="AD" clId="Web-{5A9A6002-D6C4-9C6A-4B99-0C02C916C6B5}" dt="2025-10-01T15:56:17.022" v="97" actId="1076"/>
-          <ac:spMkLst>
-            <pc:docMk/>
-            <pc:sldMk cId="2352843823" sldId="264"/>
-            <ac:spMk id="26" creationId="{FEE9FA3F-FEBC-A8CE-FEE4-93BE092A74CC}"/>
-          </ac:spMkLst>
-        </pc:spChg>
-        <pc:spChg chg="mod">
-          <ac:chgData name="Enrique Hernandez Laredo" userId="S::ehernandezl@uaemex.mx::0a776dbf-440b-483b-8adc-ce2eaa375c6c" providerId="AD" clId="Web-{5A9A6002-D6C4-9C6A-4B99-0C02C916C6B5}" dt="2025-10-01T15:56:17.054" v="99" actId="1076"/>
-          <ac:spMkLst>
-            <pc:docMk/>
-            <pc:sldMk cId="2352843823" sldId="264"/>
-            <ac:spMk id="27" creationId="{9E56EEA9-022F-89A9-5F8A-13E412ACC08D}"/>
-          </ac:spMkLst>
-        </pc:spChg>
-        <pc:picChg chg="add mod ord">
-          <ac:chgData name="Enrique Hernandez Laredo" userId="S::ehernandezl@uaemex.mx::0a776dbf-440b-483b-8adc-ce2eaa375c6c" providerId="AD" clId="Web-{5A9A6002-D6C4-9C6A-4B99-0C02C916C6B5}" dt="2025-10-01T15:52:48.554" v="74" actId="1076"/>
-          <ac:picMkLst>
-            <pc:docMk/>
-            <pc:sldMk cId="2352843823" sldId="264"/>
-            <ac:picMk id="3" creationId="{6FC6DB6F-D876-F2F5-A0A4-2E9D733E5B3D}"/>
-          </ac:picMkLst>
-        </pc:picChg>
-        <pc:picChg chg="add mod ord">
-          <ac:chgData name="Enrique Hernandez Laredo" userId="S::ehernandezl@uaemex.mx::0a776dbf-440b-483b-8adc-ce2eaa375c6c" providerId="AD" clId="Web-{5A9A6002-D6C4-9C6A-4B99-0C02C916C6B5}" dt="2025-10-01T15:56:22.897" v="100"/>
-          <ac:picMkLst>
-            <pc:docMk/>
-            <pc:sldMk cId="2352843823" sldId="264"/>
-            <ac:picMk id="5" creationId="{36E1F9E4-373F-5147-7468-696F799B22BD}"/>
-          </ac:picMkLst>
-        </pc:picChg>
-        <pc:picChg chg="del">
-          <ac:chgData name="Enrique Hernandez Laredo" userId="S::ehernandezl@uaemex.mx::0a776dbf-440b-483b-8adc-ce2eaa375c6c" providerId="AD" clId="Web-{5A9A6002-D6C4-9C6A-4B99-0C02C916C6B5}" dt="2025-10-01T15:52:08.038" v="63"/>
-          <ac:picMkLst>
-            <pc:docMk/>
-            <pc:sldMk cId="2352843823" sldId="264"/>
-            <ac:picMk id="8" creationId="{E5A2112C-9111-BE65-60D6-82DEE4860469}"/>
-          </ac:picMkLst>
-        </pc:picChg>
-        <pc:picChg chg="del">
-          <ac:chgData name="Enrique Hernandez Laredo" userId="S::ehernandezl@uaemex.mx::0a776dbf-440b-483b-8adc-ce2eaa375c6c" providerId="AD" clId="Web-{5A9A6002-D6C4-9C6A-4B99-0C02C916C6B5}" dt="2025-10-01T15:52:07.132" v="62"/>
-          <ac:picMkLst>
-            <pc:docMk/>
-            <pc:sldMk cId="2352843823" sldId="264"/>
-            <ac:picMk id="11" creationId="{40F32683-B7A6-3B10-ED27-E90D5C43D3EE}"/>
-          </ac:picMkLst>
-        </pc:picChg>
-        <pc:picChg chg="del">
-          <ac:chgData name="Enrique Hernandez Laredo" userId="S::ehernandezl@uaemex.mx::0a776dbf-440b-483b-8adc-ce2eaa375c6c" providerId="AD" clId="Web-{5A9A6002-D6C4-9C6A-4B99-0C02C916C6B5}" dt="2025-10-01T15:55:58.163" v="90"/>
-          <ac:picMkLst>
-            <pc:docMk/>
-            <pc:sldMk cId="2352843823" sldId="264"/>
-            <ac:picMk id="13" creationId="{12B25931-1B3E-BD0B-D8D2-2316820CD722}"/>
-          </ac:picMkLst>
-        </pc:picChg>
-        <pc:picChg chg="mod">
-          <ac:chgData name="Enrique Hernandez Laredo" userId="S::ehernandezl@uaemex.mx::0a776dbf-440b-483b-8adc-ce2eaa375c6c" providerId="AD" clId="Web-{5A9A6002-D6C4-9C6A-4B99-0C02C916C6B5}" dt="2025-10-01T15:56:16.991" v="95" actId="1076"/>
-          <ac:picMkLst>
-            <pc:docMk/>
-            <pc:sldMk cId="2352843823" sldId="264"/>
-            <ac:picMk id="16" creationId="{495260CA-ED27-49E8-FC32-9621FCB0F555}"/>
-          </ac:picMkLst>
-        </pc:picChg>
-        <pc:picChg chg="mod">
-          <ac:chgData name="Enrique Hernandez Laredo" userId="S::ehernandezl@uaemex.mx::0a776dbf-440b-483b-8adc-ce2eaa375c6c" providerId="AD" clId="Web-{5A9A6002-D6C4-9C6A-4B99-0C02C916C6B5}" dt="2025-10-01T15:56:17.007" v="96" actId="1076"/>
-          <ac:picMkLst>
-            <pc:docMk/>
-            <pc:sldMk cId="2352843823" sldId="264"/>
-            <ac:picMk id="17" creationId="{7EE3CFB6-9971-9441-C931-D66C39F4F9D7}"/>
-          </ac:picMkLst>
-        </pc:picChg>
-      </pc:sldChg>
-    </pc:docChg>
-  </pc:docChgLst>
-</pc:chgInfo>
-</file>
-
 <file path=ppt/notesMasters/notesMaster1.xml><?xml version="1.0" encoding="utf-8"?>
 <p:notesMaster xmlns:a="http://schemas.openxmlformats.org/drawingml/2006/main" xmlns:r="http://schemas.openxmlformats.org/officeDocument/2006/relationships" xmlns:p="http://schemas.openxmlformats.org/presentationml/2006/main">
   <p:cSld>
@@ -517,7 +204,7 @@
           <a:p>
             <a:fld id="{982820B5-36C0-4794-9E01-220C2D3A21D1}" type="datetimeFigureOut">
               <a:rPr lang="en-US" smtClean="0"/>
-              <a:t>10/1/2025</a:t>
+              <a:t>5/4/2026</a:t>
             </a:fld>
             <a:endParaRPr lang="en-US"/>
           </a:p>
@@ -6087,8 +5774,8 @@
 </file>
 
 <file path=customXml/item3.xml><?xml version="1.0" encoding="utf-8"?>
-<ct:contentTypeSchema xmlns:ct="http://schemas.microsoft.com/office/2006/metadata/contentType" xmlns:ma="http://schemas.microsoft.com/office/2006/metadata/properties/metaAttributes" ct:_="" ma:_="" ma:contentTypeName="Document" ma:contentTypeID="0x010100EC4F178DD8AD5D42B7E54A64C7A32259" ma:contentTypeVersion="13" ma:contentTypeDescription="Create a new document." ma:contentTypeScope="" ma:versionID="54b40138b4a9bf238731f94c1d996c9a">
-  <xsd:schema xmlns:xsd="http://www.w3.org/2001/XMLSchema" xmlns:xs="http://www.w3.org/2001/XMLSchema" xmlns:p="http://schemas.microsoft.com/office/2006/metadata/properties" xmlns:ns2="da2f274f-5e6c-4126-98a1-686d90f0b627" xmlns:ns3="098f7cbb-c9e9-450d-82ba-91729ba27895" targetNamespace="http://schemas.microsoft.com/office/2006/metadata/properties" ma:root="true" ma:fieldsID="aa3fc28c7022aeac332799341cfdc5e2" ns2:_="" ns3:_="">
+<ct:contentTypeSchema xmlns:ct="http://schemas.microsoft.com/office/2006/metadata/contentType" xmlns:ma="http://schemas.microsoft.com/office/2006/metadata/properties/metaAttributes" ct:_="" ma:_="" ma:contentTypeName="Document" ma:contentTypeID="0x010100EC4F178DD8AD5D42B7E54A64C7A32259" ma:contentTypeVersion="13" ma:contentTypeDescription="Create a new document." ma:contentTypeScope="" ma:versionID="94ec251bac65f007d594976d1f66ecc6">
+  <xsd:schema xmlns:xsd="http://www.w3.org/2001/XMLSchema" xmlns:xs="http://www.w3.org/2001/XMLSchema" xmlns:p="http://schemas.microsoft.com/office/2006/metadata/properties" xmlns:ns2="da2f274f-5e6c-4126-98a1-686d90f0b627" xmlns:ns3="098f7cbb-c9e9-450d-82ba-91729ba27895" targetNamespace="http://schemas.microsoft.com/office/2006/metadata/properties" ma:root="true" ma:fieldsID="ac1bd02fc6a6cf5ca99f579d85f7d5d7" ns2:_="" ns3:_="">
     <xsd:import namespace="da2f274f-5e6c-4126-98a1-686d90f0b627"/>
     <xsd:import namespace="098f7cbb-c9e9-450d-82ba-91729ba27895"/>
     <xsd:element name="properties">
@@ -6298,6 +5985,8 @@
   <ds:schemaRefs>
     <ds:schemaRef ds:uri="http://schemas.microsoft.com/office/2006/metadata/properties"/>
     <ds:schemaRef ds:uri="http://schemas.microsoft.com/office/infopath/2007/PartnerControls"/>
+    <ds:schemaRef ds:uri="098f7cbb-c9e9-450d-82ba-91729ba27895"/>
+    <ds:schemaRef ds:uri="da2f274f-5e6c-4126-98a1-686d90f0b627"/>
   </ds:schemaRefs>
 </ds:datastoreItem>
 </file>
@@ -6311,5 +6000,20 @@
 </file>
 
 <file path=customXml/itemProps3.xml><?xml version="1.0" encoding="utf-8"?>
-<ds:datastoreItem xmlns:ds="http://schemas.openxmlformats.org/officeDocument/2006/customXml" ds:itemID="{AF8BAE69-145A-48DC-9359-EF7DC776F877}"/>
+<ds:datastoreItem xmlns:ds="http://schemas.openxmlformats.org/officeDocument/2006/customXml" ds:itemID="{066C32CB-A3FD-40FE-89E3-E05EEA9E1291}">
+  <ds:schemaRefs>
+    <ds:schemaRef ds:uri="http://schemas.microsoft.com/office/2006/metadata/contentType"/>
+    <ds:schemaRef ds:uri="http://schemas.microsoft.com/office/2006/metadata/properties/metaAttributes"/>
+    <ds:schemaRef ds:uri="http://www.w3.org/2001/XMLSchema"/>
+    <ds:schemaRef ds:uri="http://schemas.microsoft.com/office/2006/metadata/properties"/>
+    <ds:schemaRef ds:uri="da2f274f-5e6c-4126-98a1-686d90f0b627"/>
+    <ds:schemaRef ds:uri="098f7cbb-c9e9-450d-82ba-91729ba27895"/>
+    <ds:schemaRef ds:uri="http://schemas.microsoft.com/office/2006/documentManagement/types"/>
+    <ds:schemaRef ds:uri="http://schemas.microsoft.com/office/infopath/2007/PartnerControls"/>
+    <ds:schemaRef ds:uri="http://schemas.openxmlformats.org/package/2006/metadata/core-properties"/>
+    <ds:schemaRef ds:uri="http://purl.org/dc/elements/1.1/"/>
+    <ds:schemaRef ds:uri="http://purl.org/dc/terms/"/>
+    <ds:schemaRef ds:uri="http://schemas.microsoft.com/internal/obd"/>
+  </ds:schemaRefs>
+</ds:datastoreItem>
 </file>
</xml_diff>